<commit_message>
KZ scientists carousel: colour each scientist by his science
Co-Authored-By: Claude Opus 5.5 <noreply@anthropic.com>
Claude-Session: https://claude.ai/code/session_01EUKBNPzc7y2DXSfnei23HU
</commit_message>
<xml_diff>
--- a/social/pptx/kz-scientists.pptx
+++ b/social/pptx/kz-scientists.pptx
@@ -1812,7 +1812,7 @@
             <a:r>
               <a:rPr lang="en-US" sz="3500" i="1" dirty="0">
                 <a:solidFill>
-                  <a:srgbClr val="0A0A0A"/>
+                  <a:srgbClr val="9C4F22"/>
                 </a:solidFill>
                 <a:latin typeface="Noto Serif Display Light" pitchFamily="34" charset="0"/>
                 <a:ea typeface="Noto Serif Display Light" pitchFamily="34" charset="-122"/>
@@ -1878,7 +1878,7 @@
             <a:r>
               <a:rPr lang="en-US" sz="3500" i="1" dirty="0">
                 <a:solidFill>
-                  <a:srgbClr val="0A0A0A"/>
+                  <a:srgbClr val="1B6676"/>
                 </a:solidFill>
                 <a:latin typeface="Noto Serif Display Light" pitchFamily="34" charset="0"/>
                 <a:ea typeface="Noto Serif Display Light" pitchFamily="34" charset="-122"/>
@@ -1944,7 +1944,7 @@
             <a:r>
               <a:rPr lang="en-US" sz="3500" i="1" dirty="0">
                 <a:solidFill>
-                  <a:srgbClr val="0A0A0A"/>
+                  <a:srgbClr val="5B2E91"/>
                 </a:solidFill>
                 <a:latin typeface="Noto Serif Display Light" pitchFamily="34" charset="0"/>
                 <a:ea typeface="Noto Serif Display Light" pitchFamily="34" charset="-122"/>
@@ -2010,7 +2010,7 @@
             <a:r>
               <a:rPr lang="en-US" sz="3500" i="1" dirty="0">
                 <a:solidFill>
-                  <a:srgbClr val="0A0A0A"/>
+                  <a:srgbClr val="2338A0"/>
                 </a:solidFill>
                 <a:latin typeface="Noto Serif Display Light" pitchFamily="34" charset="0"/>
                 <a:ea typeface="Noto Serif Display Light" pitchFamily="34" charset="-122"/>
@@ -2076,7 +2076,7 @@
             <a:r>
               <a:rPr lang="en-US" sz="3500" i="1" dirty="0">
                 <a:solidFill>
-                  <a:srgbClr val="0A0A0A"/>
+                  <a:srgbClr val="2F7A33"/>
                 </a:solidFill>
                 <a:latin typeface="Noto Serif Display Light" pitchFamily="34" charset="0"/>
                 <a:ea typeface="Noto Serif Display Light" pitchFamily="34" charset="-122"/>
@@ -3077,7 +3077,7 @@
           </a:solidFill>
           <a:ln w="12700">
             <a:solidFill>
-              <a:srgbClr val="0A0A0A"/>
+              <a:srgbClr val="9C4F22"/>
             </a:solidFill>
             <a:prstDash val="solid"/>
           </a:ln>
@@ -3137,7 +3137,7 @@
             <a:r>
               <a:rPr lang="en-US" sz="1000" spc="140" kern="0" dirty="0">
                 <a:solidFill>
-                  <a:srgbClr val="0A0A0A"/>
+                  <a:srgbClr val="9C4F22"/>
                 </a:solidFill>
                 <a:latin typeface="IBM Plex Mono" pitchFamily="34" charset="0"/>
                 <a:ea typeface="IBM Plex Mono" pitchFamily="34" charset="-122"/>
@@ -3193,7 +3193,27 @@
       </p:sp>
       <p:sp>
         <p:nvSpPr>
-          <p:cNvPr id="6" name="text-5"/>
+          <p:cNvPr id="6" name="shape-5"/>
+          <p:cNvSpPr/>
+          <p:nvPr/>
+        </p:nvSpPr>
+        <p:spPr>
+          <a:xfrm>
+            <a:off x="0" y="0"/>
+            <a:ext cx="6858000" cy="88900"/>
+          </a:xfrm>
+          <a:prstGeom prst="rect">
+            <a:avLst/>
+          </a:prstGeom>
+          <a:solidFill>
+            <a:srgbClr val="9C4F22"/>
+          </a:solidFill>
+          <a:ln/>
+        </p:spPr>
+      </p:sp>
+      <p:sp>
+        <p:nvSpPr>
+          <p:cNvPr id="7" name="text-6"/>
           <p:cNvSpPr txBox="1"/>
           <p:nvPr/>
         </p:nvSpPr>
@@ -3238,7 +3258,7 @@
             <a:r>
               <a:rPr lang="en-US" sz="5200" i="1" spc="-100" kern="0" dirty="0">
                 <a:solidFill>
-                  <a:srgbClr val="0A0A0A"/>
+                  <a:srgbClr val="9C4F22"/>
                 </a:solidFill>
                 <a:latin typeface="Noto Serif Display Light" pitchFamily="34" charset="0"/>
                 <a:ea typeface="Noto Serif Display Light" pitchFamily="34" charset="-122"/>
@@ -3252,7 +3272,7 @@
       </p:sp>
       <p:sp>
         <p:nvSpPr>
-          <p:cNvPr id="7" name="shape-6"/>
+          <p:cNvPr id="8" name="shape-7"/>
           <p:cNvSpPr/>
           <p:nvPr/>
         </p:nvSpPr>
@@ -3279,7 +3299,7 @@
       </p:sp>
       <p:sp>
         <p:nvSpPr>
-          <p:cNvPr id="8" name="shape-7"/>
+          <p:cNvPr id="9" name="shape-8"/>
           <p:cNvSpPr/>
           <p:nvPr/>
         </p:nvSpPr>
@@ -3301,7 +3321,7 @@
       </p:sp>
       <p:sp>
         <p:nvSpPr>
-          <p:cNvPr id="9" name="text-8"/>
+          <p:cNvPr id="10" name="text-9"/>
           <p:cNvSpPr txBox="1"/>
           <p:nvPr/>
         </p:nvSpPr>
@@ -3343,7 +3363,7 @@
       </p:sp>
       <p:sp>
         <p:nvSpPr>
-          <p:cNvPr id="10" name="text-9"/>
+          <p:cNvPr id="11" name="text-10"/>
           <p:cNvSpPr txBox="1"/>
           <p:nvPr/>
         </p:nvSpPr>
@@ -3385,7 +3405,7 @@
       </p:sp>
       <p:sp>
         <p:nvSpPr>
-          <p:cNvPr id="11" name="text-10"/>
+          <p:cNvPr id="12" name="text-11"/>
           <p:cNvSpPr txBox="1"/>
           <p:nvPr/>
         </p:nvSpPr>
@@ -3427,7 +3447,7 @@
       </p:sp>
       <p:sp>
         <p:nvSpPr>
-          <p:cNvPr id="12" name="shape-11"/>
+          <p:cNvPr id="13" name="shape-12"/>
           <p:cNvSpPr/>
           <p:nvPr/>
         </p:nvSpPr>
@@ -3442,14 +3462,14 @@
             </a:avLst>
           </a:prstGeom>
           <a:solidFill>
-            <a:srgbClr val="0A0A0A"/>
+            <a:srgbClr val="9C4F22"/>
           </a:solidFill>
           <a:ln/>
         </p:spPr>
       </p:sp>
       <p:sp>
         <p:nvSpPr>
-          <p:cNvPr id="13" name="shape-12"/>
+          <p:cNvPr id="14" name="shape-13"/>
           <p:cNvSpPr/>
           <p:nvPr/>
         </p:nvSpPr>
@@ -3466,7 +3486,7 @@
           </a:solidFill>
           <a:ln w="12700">
             <a:solidFill>
-              <a:srgbClr val="0A0A0A"/>
+              <a:srgbClr val="9C4F22"/>
             </a:solidFill>
             <a:prstDash val="solid"/>
           </a:ln>
@@ -3474,7 +3494,7 @@
       </p:sp>
       <p:pic>
         <p:nvPicPr>
-          <p:cNvPr id="14" name="svg-13" descr="preencoded.png">    </p:cNvPr>
+          <p:cNvPr id="15" name="svg-14" descr="preencoded.png">    </p:cNvPr>
           <p:cNvPicPr>
             <a:picLocks noChangeAspect="1"/>
           </p:cNvPicPr>
@@ -3498,7 +3518,7 @@
       </p:pic>
       <p:sp>
         <p:nvSpPr>
-          <p:cNvPr id="15" name="text-14"/>
+          <p:cNvPr id="16" name="text-15"/>
           <p:cNvSpPr txBox="1"/>
           <p:nvPr/>
         </p:nvSpPr>
@@ -3540,7 +3560,7 @@
       </p:sp>
       <p:pic>
         <p:nvPicPr>
-          <p:cNvPr id="16" name="svg-15" descr="preencoded.png">    </p:cNvPr>
+          <p:cNvPr id="17" name="svg-16" descr="preencoded.png">    </p:cNvPr>
           <p:cNvPicPr>
             <a:picLocks noChangeAspect="1"/>
           </p:cNvPicPr>
@@ -3564,7 +3584,7 @@
       </p:pic>
       <p:sp>
         <p:nvSpPr>
-          <p:cNvPr id="17" name="text-16"/>
+          <p:cNvPr id="18" name="text-17"/>
           <p:cNvSpPr txBox="1"/>
           <p:nvPr/>
         </p:nvSpPr>
@@ -3606,7 +3626,7 @@
       </p:sp>
       <p:sp>
         <p:nvSpPr>
-          <p:cNvPr id="18" name="text-17"/>
+          <p:cNvPr id="19" name="text-18"/>
           <p:cNvSpPr txBox="1"/>
           <p:nvPr/>
         </p:nvSpPr>
@@ -3648,7 +3668,7 @@
       </p:sp>
       <p:sp>
         <p:nvSpPr>
-          <p:cNvPr id="19" name="text-18"/>
+          <p:cNvPr id="20" name="text-19"/>
           <p:cNvSpPr txBox="1"/>
           <p:nvPr/>
         </p:nvSpPr>
@@ -3690,7 +3710,7 @@
       </p:sp>
       <p:sp>
         <p:nvSpPr>
-          <p:cNvPr id="20" name="text-19"/>
+          <p:cNvPr id="21" name="text-20"/>
           <p:cNvSpPr txBox="1"/>
           <p:nvPr/>
         </p:nvSpPr>
@@ -3732,7 +3752,7 @@
       </p:sp>
       <p:sp>
         <p:nvSpPr>
-          <p:cNvPr id="21" name="shape-20"/>
+          <p:cNvPr id="22" name="shape-21"/>
           <p:cNvSpPr/>
           <p:nvPr/>
         </p:nvSpPr>
@@ -3754,7 +3774,7 @@
       </p:sp>
       <p:sp>
         <p:nvSpPr>
-          <p:cNvPr id="22" name="text-21"/>
+          <p:cNvPr id="23" name="text-22"/>
           <p:cNvSpPr txBox="1"/>
           <p:nvPr/>
         </p:nvSpPr>
@@ -3796,7 +3816,7 @@
       </p:sp>
       <p:pic>
         <p:nvPicPr>
-          <p:cNvPr id="23" name="svg-22" descr="preencoded.png">    </p:cNvPr>
+          <p:cNvPr id="24" name="svg-23" descr="preencoded.png">    </p:cNvPr>
           <p:cNvPicPr>
             <a:picLocks noChangeAspect="1"/>
           </p:cNvPicPr>
@@ -3820,7 +3840,7 @@
       </p:pic>
       <p:sp>
         <p:nvSpPr>
-          <p:cNvPr id="24" name="shape-23"/>
+          <p:cNvPr id="25" name="shape-24"/>
           <p:cNvSpPr/>
           <p:nvPr/>
         </p:nvSpPr>
@@ -3847,7 +3867,7 @@
       </p:sp>
       <p:sp>
         <p:nvSpPr>
-          <p:cNvPr id="25" name="shape-24"/>
+          <p:cNvPr id="26" name="shape-25"/>
           <p:cNvSpPr/>
           <p:nvPr/>
         </p:nvSpPr>
@@ -3869,7 +3889,7 @@
       </p:sp>
       <p:pic>
         <p:nvPicPr>
-          <p:cNvPr id="26" name="img-25" descr="preencoded.png">    </p:cNvPr>
+          <p:cNvPr id="27" name="img-26" descr="preencoded.png">    </p:cNvPr>
           <p:cNvPicPr>
             <a:picLocks noChangeAspect="1"/>
           </p:cNvPicPr>
@@ -3893,7 +3913,7 @@
       </p:pic>
       <p:sp>
         <p:nvSpPr>
-          <p:cNvPr id="27" name="text-26"/>
+          <p:cNvPr id="28" name="text-27"/>
           <p:cNvSpPr txBox="1"/>
           <p:nvPr/>
         </p:nvSpPr>
@@ -3935,7 +3955,7 @@
       </p:sp>
       <p:sp>
         <p:nvSpPr>
-          <p:cNvPr id="28" name="text-27"/>
+          <p:cNvPr id="29" name="text-28"/>
           <p:cNvSpPr txBox="1"/>
           <p:nvPr/>
         </p:nvSpPr>
@@ -4035,7 +4055,7 @@
           </a:solidFill>
           <a:ln w="12700">
             <a:solidFill>
-              <a:srgbClr val="0A0A0A"/>
+              <a:srgbClr val="1B6676"/>
             </a:solidFill>
             <a:prstDash val="solid"/>
           </a:ln>
@@ -4095,7 +4115,7 @@
             <a:r>
               <a:rPr lang="en-US" sz="1000" spc="140" kern="0" dirty="0">
                 <a:solidFill>
-                  <a:srgbClr val="0A0A0A"/>
+                  <a:srgbClr val="1B6676"/>
                 </a:solidFill>
                 <a:latin typeface="IBM Plex Mono" pitchFamily="34" charset="0"/>
                 <a:ea typeface="IBM Plex Mono" pitchFamily="34" charset="-122"/>
@@ -4151,7 +4171,27 @@
       </p:sp>
       <p:sp>
         <p:nvSpPr>
-          <p:cNvPr id="6" name="text-5"/>
+          <p:cNvPr id="6" name="shape-5"/>
+          <p:cNvSpPr/>
+          <p:nvPr/>
+        </p:nvSpPr>
+        <p:spPr>
+          <a:xfrm>
+            <a:off x="0" y="0"/>
+            <a:ext cx="6858000" cy="88900"/>
+          </a:xfrm>
+          <a:prstGeom prst="rect">
+            <a:avLst/>
+          </a:prstGeom>
+          <a:solidFill>
+            <a:srgbClr val="1B6676"/>
+          </a:solidFill>
+          <a:ln/>
+        </p:spPr>
+      </p:sp>
+      <p:sp>
+        <p:nvSpPr>
+          <p:cNvPr id="7" name="text-6"/>
           <p:cNvSpPr txBox="1"/>
           <p:nvPr/>
         </p:nvSpPr>
@@ -4196,7 +4236,7 @@
             <a:r>
               <a:rPr lang="en-US" sz="5200" i="1" spc="-100" kern="0" dirty="0">
                 <a:solidFill>
-                  <a:srgbClr val="0A0A0A"/>
+                  <a:srgbClr val="1B6676"/>
                 </a:solidFill>
                 <a:latin typeface="Noto Serif Display Light" pitchFamily="34" charset="0"/>
                 <a:ea typeface="Noto Serif Display Light" pitchFamily="34" charset="-122"/>
@@ -4210,7 +4250,7 @@
       </p:sp>
       <p:sp>
         <p:nvSpPr>
-          <p:cNvPr id="7" name="shape-6"/>
+          <p:cNvPr id="8" name="shape-7"/>
           <p:cNvSpPr/>
           <p:nvPr/>
         </p:nvSpPr>
@@ -4237,7 +4277,7 @@
       </p:sp>
       <p:sp>
         <p:nvSpPr>
-          <p:cNvPr id="8" name="shape-7"/>
+          <p:cNvPr id="9" name="shape-8"/>
           <p:cNvSpPr/>
           <p:nvPr/>
         </p:nvSpPr>
@@ -4259,7 +4299,7 @@
       </p:sp>
       <p:sp>
         <p:nvSpPr>
-          <p:cNvPr id="9" name="text-8"/>
+          <p:cNvPr id="10" name="text-9"/>
           <p:cNvSpPr txBox="1"/>
           <p:nvPr/>
         </p:nvSpPr>
@@ -4301,7 +4341,7 @@
       </p:sp>
       <p:sp>
         <p:nvSpPr>
-          <p:cNvPr id="10" name="text-9"/>
+          <p:cNvPr id="11" name="text-10"/>
           <p:cNvSpPr txBox="1"/>
           <p:nvPr/>
         </p:nvSpPr>
@@ -4343,7 +4383,7 @@
       </p:sp>
       <p:sp>
         <p:nvSpPr>
-          <p:cNvPr id="11" name="text-10"/>
+          <p:cNvPr id="12" name="text-11"/>
           <p:cNvSpPr txBox="1"/>
           <p:nvPr/>
         </p:nvSpPr>
@@ -4385,7 +4425,7 @@
       </p:sp>
       <p:sp>
         <p:nvSpPr>
-          <p:cNvPr id="12" name="shape-11"/>
+          <p:cNvPr id="13" name="shape-12"/>
           <p:cNvSpPr/>
           <p:nvPr/>
         </p:nvSpPr>
@@ -4400,14 +4440,14 @@
             </a:avLst>
           </a:prstGeom>
           <a:solidFill>
-            <a:srgbClr val="0A0A0A"/>
+            <a:srgbClr val="1B6676"/>
           </a:solidFill>
           <a:ln/>
         </p:spPr>
       </p:sp>
       <p:sp>
         <p:nvSpPr>
-          <p:cNvPr id="13" name="shape-12"/>
+          <p:cNvPr id="14" name="shape-13"/>
           <p:cNvSpPr/>
           <p:nvPr/>
         </p:nvSpPr>
@@ -4424,7 +4464,7 @@
           </a:solidFill>
           <a:ln w="12700">
             <a:solidFill>
-              <a:srgbClr val="0A0A0A"/>
+              <a:srgbClr val="1B6676"/>
             </a:solidFill>
             <a:prstDash val="solid"/>
           </a:ln>
@@ -4432,7 +4472,7 @@
       </p:sp>
       <p:pic>
         <p:nvPicPr>
-          <p:cNvPr id="14" name="svg-13" descr="preencoded.png">    </p:cNvPr>
+          <p:cNvPr id="15" name="svg-14" descr="preencoded.png">    </p:cNvPr>
           <p:cNvPicPr>
             <a:picLocks noChangeAspect="1"/>
           </p:cNvPicPr>
@@ -4456,7 +4496,7 @@
       </p:pic>
       <p:sp>
         <p:nvSpPr>
-          <p:cNvPr id="15" name="text-14"/>
+          <p:cNvPr id="16" name="text-15"/>
           <p:cNvSpPr txBox="1"/>
           <p:nvPr/>
         </p:nvSpPr>
@@ -4498,7 +4538,7 @@
       </p:sp>
       <p:pic>
         <p:nvPicPr>
-          <p:cNvPr id="16" name="svg-15" descr="preencoded.png">    </p:cNvPr>
+          <p:cNvPr id="17" name="svg-16" descr="preencoded.png">    </p:cNvPr>
           <p:cNvPicPr>
             <a:picLocks noChangeAspect="1"/>
           </p:cNvPicPr>
@@ -4522,7 +4562,7 @@
       </p:pic>
       <p:sp>
         <p:nvSpPr>
-          <p:cNvPr id="17" name="text-16"/>
+          <p:cNvPr id="18" name="text-17"/>
           <p:cNvSpPr txBox="1"/>
           <p:nvPr/>
         </p:nvSpPr>
@@ -4564,7 +4604,7 @@
       </p:sp>
       <p:sp>
         <p:nvSpPr>
-          <p:cNvPr id="18" name="text-17"/>
+          <p:cNvPr id="19" name="text-18"/>
           <p:cNvSpPr txBox="1"/>
           <p:nvPr/>
         </p:nvSpPr>
@@ -4606,7 +4646,7 @@
       </p:sp>
       <p:sp>
         <p:nvSpPr>
-          <p:cNvPr id="19" name="text-18"/>
+          <p:cNvPr id="20" name="text-19"/>
           <p:cNvSpPr txBox="1"/>
           <p:nvPr/>
         </p:nvSpPr>
@@ -4648,7 +4688,7 @@
       </p:sp>
       <p:sp>
         <p:nvSpPr>
-          <p:cNvPr id="20" name="text-19"/>
+          <p:cNvPr id="21" name="text-20"/>
           <p:cNvSpPr txBox="1"/>
           <p:nvPr/>
         </p:nvSpPr>
@@ -4690,7 +4730,7 @@
       </p:sp>
       <p:sp>
         <p:nvSpPr>
-          <p:cNvPr id="21" name="shape-20"/>
+          <p:cNvPr id="22" name="shape-21"/>
           <p:cNvSpPr/>
           <p:nvPr/>
         </p:nvSpPr>
@@ -4712,7 +4752,7 @@
       </p:sp>
       <p:sp>
         <p:nvSpPr>
-          <p:cNvPr id="22" name="text-21"/>
+          <p:cNvPr id="23" name="text-22"/>
           <p:cNvSpPr txBox="1"/>
           <p:nvPr/>
         </p:nvSpPr>
@@ -4754,7 +4794,7 @@
       </p:sp>
       <p:pic>
         <p:nvPicPr>
-          <p:cNvPr id="23" name="svg-22" descr="preencoded.png">    </p:cNvPr>
+          <p:cNvPr id="24" name="svg-23" descr="preencoded.png">    </p:cNvPr>
           <p:cNvPicPr>
             <a:picLocks noChangeAspect="1"/>
           </p:cNvPicPr>
@@ -4778,7 +4818,7 @@
       </p:pic>
       <p:sp>
         <p:nvSpPr>
-          <p:cNvPr id="24" name="shape-23"/>
+          <p:cNvPr id="25" name="shape-24"/>
           <p:cNvSpPr/>
           <p:nvPr/>
         </p:nvSpPr>
@@ -4805,7 +4845,7 @@
       </p:sp>
       <p:sp>
         <p:nvSpPr>
-          <p:cNvPr id="25" name="shape-24"/>
+          <p:cNvPr id="26" name="shape-25"/>
           <p:cNvSpPr/>
           <p:nvPr/>
         </p:nvSpPr>
@@ -4827,7 +4867,7 @@
       </p:sp>
       <p:pic>
         <p:nvPicPr>
-          <p:cNvPr id="26" name="img-25" descr="preencoded.png">    </p:cNvPr>
+          <p:cNvPr id="27" name="img-26" descr="preencoded.png">    </p:cNvPr>
           <p:cNvPicPr>
             <a:picLocks noChangeAspect="1"/>
           </p:cNvPicPr>
@@ -4851,7 +4891,7 @@
       </p:pic>
       <p:sp>
         <p:nvSpPr>
-          <p:cNvPr id="27" name="text-26"/>
+          <p:cNvPr id="28" name="text-27"/>
           <p:cNvSpPr txBox="1"/>
           <p:nvPr/>
         </p:nvSpPr>
@@ -4893,7 +4933,7 @@
       </p:sp>
       <p:sp>
         <p:nvSpPr>
-          <p:cNvPr id="28" name="text-27"/>
+          <p:cNvPr id="29" name="text-28"/>
           <p:cNvSpPr txBox="1"/>
           <p:nvPr/>
         </p:nvSpPr>
@@ -4993,7 +5033,7 @@
           </a:solidFill>
           <a:ln w="12700">
             <a:solidFill>
-              <a:srgbClr val="0A0A0A"/>
+              <a:srgbClr val="5B2E91"/>
             </a:solidFill>
             <a:prstDash val="solid"/>
           </a:ln>
@@ -5053,7 +5093,7 @@
             <a:r>
               <a:rPr lang="en-US" sz="1000" spc="140" kern="0" dirty="0">
                 <a:solidFill>
-                  <a:srgbClr val="0A0A0A"/>
+                  <a:srgbClr val="5B2E91"/>
                 </a:solidFill>
                 <a:latin typeface="IBM Plex Mono" pitchFamily="34" charset="0"/>
                 <a:ea typeface="IBM Plex Mono" pitchFamily="34" charset="-122"/>
@@ -5109,7 +5149,27 @@
       </p:sp>
       <p:sp>
         <p:nvSpPr>
-          <p:cNvPr id="6" name="text-5"/>
+          <p:cNvPr id="6" name="shape-5"/>
+          <p:cNvSpPr/>
+          <p:nvPr/>
+        </p:nvSpPr>
+        <p:spPr>
+          <a:xfrm>
+            <a:off x="0" y="0"/>
+            <a:ext cx="6858000" cy="88900"/>
+          </a:xfrm>
+          <a:prstGeom prst="rect">
+            <a:avLst/>
+          </a:prstGeom>
+          <a:solidFill>
+            <a:srgbClr val="5B2E91"/>
+          </a:solidFill>
+          <a:ln/>
+        </p:spPr>
+      </p:sp>
+      <p:sp>
+        <p:nvSpPr>
+          <p:cNvPr id="7" name="text-6"/>
           <p:cNvSpPr txBox="1"/>
           <p:nvPr/>
         </p:nvSpPr>
@@ -5154,7 +5214,7 @@
             <a:r>
               <a:rPr lang="en-US" sz="5200" i="1" spc="-100" kern="0" dirty="0">
                 <a:solidFill>
-                  <a:srgbClr val="0A0A0A"/>
+                  <a:srgbClr val="5B2E91"/>
                 </a:solidFill>
                 <a:latin typeface="Noto Serif Display Light" pitchFamily="34" charset="0"/>
                 <a:ea typeface="Noto Serif Display Light" pitchFamily="34" charset="-122"/>
@@ -5168,7 +5228,7 @@
       </p:sp>
       <p:sp>
         <p:nvSpPr>
-          <p:cNvPr id="7" name="shape-6"/>
+          <p:cNvPr id="8" name="shape-7"/>
           <p:cNvSpPr/>
           <p:nvPr/>
         </p:nvSpPr>
@@ -5195,7 +5255,7 @@
       </p:sp>
       <p:sp>
         <p:nvSpPr>
-          <p:cNvPr id="8" name="shape-7"/>
+          <p:cNvPr id="9" name="shape-8"/>
           <p:cNvSpPr/>
           <p:nvPr/>
         </p:nvSpPr>
@@ -5217,7 +5277,7 @@
       </p:sp>
       <p:sp>
         <p:nvSpPr>
-          <p:cNvPr id="9" name="text-8"/>
+          <p:cNvPr id="10" name="text-9"/>
           <p:cNvSpPr txBox="1"/>
           <p:nvPr/>
         </p:nvSpPr>
@@ -5259,7 +5319,7 @@
       </p:sp>
       <p:sp>
         <p:nvSpPr>
-          <p:cNvPr id="10" name="text-9"/>
+          <p:cNvPr id="11" name="text-10"/>
           <p:cNvSpPr txBox="1"/>
           <p:nvPr/>
         </p:nvSpPr>
@@ -5301,7 +5361,7 @@
       </p:sp>
       <p:sp>
         <p:nvSpPr>
-          <p:cNvPr id="11" name="text-10"/>
+          <p:cNvPr id="12" name="text-11"/>
           <p:cNvSpPr txBox="1"/>
           <p:nvPr/>
         </p:nvSpPr>
@@ -5343,7 +5403,7 @@
       </p:sp>
       <p:sp>
         <p:nvSpPr>
-          <p:cNvPr id="12" name="shape-11"/>
+          <p:cNvPr id="13" name="shape-12"/>
           <p:cNvSpPr/>
           <p:nvPr/>
         </p:nvSpPr>
@@ -5358,14 +5418,14 @@
             </a:avLst>
           </a:prstGeom>
           <a:solidFill>
-            <a:srgbClr val="0A0A0A"/>
+            <a:srgbClr val="5B2E91"/>
           </a:solidFill>
           <a:ln/>
         </p:spPr>
       </p:sp>
       <p:sp>
         <p:nvSpPr>
-          <p:cNvPr id="13" name="shape-12"/>
+          <p:cNvPr id="14" name="shape-13"/>
           <p:cNvSpPr/>
           <p:nvPr/>
         </p:nvSpPr>
@@ -5382,7 +5442,7 @@
           </a:solidFill>
           <a:ln w="12700">
             <a:solidFill>
-              <a:srgbClr val="0A0A0A"/>
+              <a:srgbClr val="5B2E91"/>
             </a:solidFill>
             <a:prstDash val="solid"/>
           </a:ln>
@@ -5390,7 +5450,7 @@
       </p:sp>
       <p:pic>
         <p:nvPicPr>
-          <p:cNvPr id="14" name="svg-13" descr="preencoded.png">    </p:cNvPr>
+          <p:cNvPr id="15" name="svg-14" descr="preencoded.png">    </p:cNvPr>
           <p:cNvPicPr>
             <a:picLocks noChangeAspect="1"/>
           </p:cNvPicPr>
@@ -5414,7 +5474,7 @@
       </p:pic>
       <p:sp>
         <p:nvSpPr>
-          <p:cNvPr id="15" name="text-14"/>
+          <p:cNvPr id="16" name="text-15"/>
           <p:cNvSpPr txBox="1"/>
           <p:nvPr/>
         </p:nvSpPr>
@@ -5456,7 +5516,7 @@
       </p:sp>
       <p:pic>
         <p:nvPicPr>
-          <p:cNvPr id="16" name="svg-15" descr="preencoded.png">    </p:cNvPr>
+          <p:cNvPr id="17" name="svg-16" descr="preencoded.png">    </p:cNvPr>
           <p:cNvPicPr>
             <a:picLocks noChangeAspect="1"/>
           </p:cNvPicPr>
@@ -5480,7 +5540,7 @@
       </p:pic>
       <p:sp>
         <p:nvSpPr>
-          <p:cNvPr id="17" name="text-16"/>
+          <p:cNvPr id="18" name="text-17"/>
           <p:cNvSpPr txBox="1"/>
           <p:nvPr/>
         </p:nvSpPr>
@@ -5522,7 +5582,7 @@
       </p:sp>
       <p:sp>
         <p:nvSpPr>
-          <p:cNvPr id="18" name="text-17"/>
+          <p:cNvPr id="19" name="text-18"/>
           <p:cNvSpPr txBox="1"/>
           <p:nvPr/>
         </p:nvSpPr>
@@ -5564,7 +5624,7 @@
       </p:sp>
       <p:sp>
         <p:nvSpPr>
-          <p:cNvPr id="19" name="text-18"/>
+          <p:cNvPr id="20" name="text-19"/>
           <p:cNvSpPr txBox="1"/>
           <p:nvPr/>
         </p:nvSpPr>
@@ -5606,7 +5666,7 @@
       </p:sp>
       <p:sp>
         <p:nvSpPr>
-          <p:cNvPr id="20" name="text-19"/>
+          <p:cNvPr id="21" name="text-20"/>
           <p:cNvSpPr txBox="1"/>
           <p:nvPr/>
         </p:nvSpPr>
@@ -5648,7 +5708,7 @@
       </p:sp>
       <p:sp>
         <p:nvSpPr>
-          <p:cNvPr id="21" name="shape-20"/>
+          <p:cNvPr id="22" name="shape-21"/>
           <p:cNvSpPr/>
           <p:nvPr/>
         </p:nvSpPr>
@@ -5670,7 +5730,7 @@
       </p:sp>
       <p:sp>
         <p:nvSpPr>
-          <p:cNvPr id="22" name="text-21"/>
+          <p:cNvPr id="23" name="text-22"/>
           <p:cNvSpPr txBox="1"/>
           <p:nvPr/>
         </p:nvSpPr>
@@ -5712,7 +5772,7 @@
       </p:sp>
       <p:pic>
         <p:nvPicPr>
-          <p:cNvPr id="23" name="svg-22" descr="preencoded.png">    </p:cNvPr>
+          <p:cNvPr id="24" name="svg-23" descr="preencoded.png">    </p:cNvPr>
           <p:cNvPicPr>
             <a:picLocks noChangeAspect="1"/>
           </p:cNvPicPr>
@@ -5736,7 +5796,7 @@
       </p:pic>
       <p:sp>
         <p:nvSpPr>
-          <p:cNvPr id="24" name="shape-23"/>
+          <p:cNvPr id="25" name="shape-24"/>
           <p:cNvSpPr/>
           <p:nvPr/>
         </p:nvSpPr>
@@ -5763,7 +5823,7 @@
       </p:sp>
       <p:sp>
         <p:nvSpPr>
-          <p:cNvPr id="25" name="shape-24"/>
+          <p:cNvPr id="26" name="shape-25"/>
           <p:cNvSpPr/>
           <p:nvPr/>
         </p:nvSpPr>
@@ -5785,7 +5845,7 @@
       </p:sp>
       <p:pic>
         <p:nvPicPr>
-          <p:cNvPr id="26" name="img-25" descr="preencoded.png">    </p:cNvPr>
+          <p:cNvPr id="27" name="img-26" descr="preencoded.png">    </p:cNvPr>
           <p:cNvPicPr>
             <a:picLocks noChangeAspect="1"/>
           </p:cNvPicPr>
@@ -5809,7 +5869,7 @@
       </p:pic>
       <p:sp>
         <p:nvSpPr>
-          <p:cNvPr id="27" name="text-26"/>
+          <p:cNvPr id="28" name="text-27"/>
           <p:cNvSpPr txBox="1"/>
           <p:nvPr/>
         </p:nvSpPr>
@@ -5851,7 +5911,7 @@
       </p:sp>
       <p:sp>
         <p:nvSpPr>
-          <p:cNvPr id="28" name="text-27"/>
+          <p:cNvPr id="29" name="text-28"/>
           <p:cNvSpPr txBox="1"/>
           <p:nvPr/>
         </p:nvSpPr>
@@ -5951,7 +6011,7 @@
           </a:solidFill>
           <a:ln w="12700">
             <a:solidFill>
-              <a:srgbClr val="0A0A0A"/>
+              <a:srgbClr val="2338A0"/>
             </a:solidFill>
             <a:prstDash val="solid"/>
           </a:ln>
@@ -6011,7 +6071,7 @@
             <a:r>
               <a:rPr lang="en-US" sz="1000" spc="140" kern="0" dirty="0">
                 <a:solidFill>
-                  <a:srgbClr val="0A0A0A"/>
+                  <a:srgbClr val="2338A0"/>
                 </a:solidFill>
                 <a:latin typeface="IBM Plex Mono" pitchFamily="34" charset="0"/>
                 <a:ea typeface="IBM Plex Mono" pitchFamily="34" charset="-122"/>
@@ -6067,7 +6127,27 @@
       </p:sp>
       <p:sp>
         <p:nvSpPr>
-          <p:cNvPr id="6" name="text-5"/>
+          <p:cNvPr id="6" name="shape-5"/>
+          <p:cNvSpPr/>
+          <p:nvPr/>
+        </p:nvSpPr>
+        <p:spPr>
+          <a:xfrm>
+            <a:off x="0" y="0"/>
+            <a:ext cx="6858000" cy="88900"/>
+          </a:xfrm>
+          <a:prstGeom prst="rect">
+            <a:avLst/>
+          </a:prstGeom>
+          <a:solidFill>
+            <a:srgbClr val="2338A0"/>
+          </a:solidFill>
+          <a:ln/>
+        </p:spPr>
+      </p:sp>
+      <p:sp>
+        <p:nvSpPr>
+          <p:cNvPr id="7" name="text-6"/>
           <p:cNvSpPr txBox="1"/>
           <p:nvPr/>
         </p:nvSpPr>
@@ -6112,7 +6192,7 @@
             <a:r>
               <a:rPr lang="en-US" sz="4000" i="1" spc="-80" kern="0" dirty="0">
                 <a:solidFill>
-                  <a:srgbClr val="0A0A0A"/>
+                  <a:srgbClr val="2338A0"/>
                 </a:solidFill>
                 <a:latin typeface="Noto Serif Display Light" pitchFamily="34" charset="0"/>
                 <a:ea typeface="Noto Serif Display Light" pitchFamily="34" charset="-122"/>
@@ -6126,7 +6206,7 @@
       </p:sp>
       <p:sp>
         <p:nvSpPr>
-          <p:cNvPr id="7" name="shape-6"/>
+          <p:cNvPr id="8" name="shape-7"/>
           <p:cNvSpPr/>
           <p:nvPr/>
         </p:nvSpPr>
@@ -6153,7 +6233,7 @@
       </p:sp>
       <p:sp>
         <p:nvSpPr>
-          <p:cNvPr id="8" name="shape-7"/>
+          <p:cNvPr id="9" name="shape-8"/>
           <p:cNvSpPr/>
           <p:nvPr/>
         </p:nvSpPr>
@@ -6175,7 +6255,7 @@
       </p:sp>
       <p:sp>
         <p:nvSpPr>
-          <p:cNvPr id="9" name="text-8"/>
+          <p:cNvPr id="10" name="text-9"/>
           <p:cNvSpPr txBox="1"/>
           <p:nvPr/>
         </p:nvSpPr>
@@ -6217,7 +6297,7 @@
       </p:sp>
       <p:sp>
         <p:nvSpPr>
-          <p:cNvPr id="10" name="text-9"/>
+          <p:cNvPr id="11" name="text-10"/>
           <p:cNvSpPr txBox="1"/>
           <p:nvPr/>
         </p:nvSpPr>
@@ -6259,7 +6339,7 @@
       </p:sp>
       <p:sp>
         <p:nvSpPr>
-          <p:cNvPr id="11" name="text-10"/>
+          <p:cNvPr id="12" name="text-11"/>
           <p:cNvSpPr txBox="1"/>
           <p:nvPr/>
         </p:nvSpPr>
@@ -6301,7 +6381,7 @@
       </p:sp>
       <p:sp>
         <p:nvSpPr>
-          <p:cNvPr id="12" name="shape-11"/>
+          <p:cNvPr id="13" name="shape-12"/>
           <p:cNvSpPr/>
           <p:nvPr/>
         </p:nvSpPr>
@@ -6316,14 +6396,14 @@
             </a:avLst>
           </a:prstGeom>
           <a:solidFill>
-            <a:srgbClr val="0A0A0A"/>
+            <a:srgbClr val="2338A0"/>
           </a:solidFill>
           <a:ln/>
         </p:spPr>
       </p:sp>
       <p:sp>
         <p:nvSpPr>
-          <p:cNvPr id="13" name="shape-12"/>
+          <p:cNvPr id="14" name="shape-13"/>
           <p:cNvSpPr/>
           <p:nvPr/>
         </p:nvSpPr>
@@ -6340,7 +6420,7 @@
           </a:solidFill>
           <a:ln w="12700">
             <a:solidFill>
-              <a:srgbClr val="0A0A0A"/>
+              <a:srgbClr val="2338A0"/>
             </a:solidFill>
             <a:prstDash val="solid"/>
           </a:ln>
@@ -6348,7 +6428,7 @@
       </p:sp>
       <p:pic>
         <p:nvPicPr>
-          <p:cNvPr id="14" name="svg-13" descr="preencoded.png">    </p:cNvPr>
+          <p:cNvPr id="15" name="svg-14" descr="preencoded.png">    </p:cNvPr>
           <p:cNvPicPr>
             <a:picLocks noChangeAspect="1"/>
           </p:cNvPicPr>
@@ -6372,7 +6452,7 @@
       </p:pic>
       <p:sp>
         <p:nvSpPr>
-          <p:cNvPr id="15" name="text-14"/>
+          <p:cNvPr id="16" name="text-15"/>
           <p:cNvSpPr txBox="1"/>
           <p:nvPr/>
         </p:nvSpPr>
@@ -6414,7 +6494,7 @@
       </p:sp>
       <p:pic>
         <p:nvPicPr>
-          <p:cNvPr id="16" name="svg-15" descr="preencoded.png">    </p:cNvPr>
+          <p:cNvPr id="17" name="svg-16" descr="preencoded.png">    </p:cNvPr>
           <p:cNvPicPr>
             <a:picLocks noChangeAspect="1"/>
           </p:cNvPicPr>
@@ -6438,7 +6518,7 @@
       </p:pic>
       <p:sp>
         <p:nvSpPr>
-          <p:cNvPr id="17" name="text-16"/>
+          <p:cNvPr id="18" name="text-17"/>
           <p:cNvSpPr txBox="1"/>
           <p:nvPr/>
         </p:nvSpPr>
@@ -6480,7 +6560,7 @@
       </p:sp>
       <p:sp>
         <p:nvSpPr>
-          <p:cNvPr id="18" name="text-17"/>
+          <p:cNvPr id="19" name="text-18"/>
           <p:cNvSpPr txBox="1"/>
           <p:nvPr/>
         </p:nvSpPr>
@@ -6522,7 +6602,7 @@
       </p:sp>
       <p:sp>
         <p:nvSpPr>
-          <p:cNvPr id="19" name="text-18"/>
+          <p:cNvPr id="20" name="text-19"/>
           <p:cNvSpPr txBox="1"/>
           <p:nvPr/>
         </p:nvSpPr>
@@ -6564,7 +6644,7 @@
       </p:sp>
       <p:sp>
         <p:nvSpPr>
-          <p:cNvPr id="20" name="text-19"/>
+          <p:cNvPr id="21" name="text-20"/>
           <p:cNvSpPr txBox="1"/>
           <p:nvPr/>
         </p:nvSpPr>
@@ -6606,7 +6686,7 @@
       </p:sp>
       <p:sp>
         <p:nvSpPr>
-          <p:cNvPr id="21" name="shape-20"/>
+          <p:cNvPr id="22" name="shape-21"/>
           <p:cNvSpPr/>
           <p:nvPr/>
         </p:nvSpPr>
@@ -6628,7 +6708,7 @@
       </p:sp>
       <p:sp>
         <p:nvSpPr>
-          <p:cNvPr id="22" name="text-21"/>
+          <p:cNvPr id="23" name="text-22"/>
           <p:cNvSpPr txBox="1"/>
           <p:nvPr/>
         </p:nvSpPr>
@@ -6670,7 +6750,7 @@
       </p:sp>
       <p:pic>
         <p:nvPicPr>
-          <p:cNvPr id="23" name="svg-22" descr="preencoded.png">    </p:cNvPr>
+          <p:cNvPr id="24" name="svg-23" descr="preencoded.png">    </p:cNvPr>
           <p:cNvPicPr>
             <a:picLocks noChangeAspect="1"/>
           </p:cNvPicPr>
@@ -6694,7 +6774,7 @@
       </p:pic>
       <p:sp>
         <p:nvSpPr>
-          <p:cNvPr id="24" name="shape-23"/>
+          <p:cNvPr id="25" name="shape-24"/>
           <p:cNvSpPr/>
           <p:nvPr/>
         </p:nvSpPr>
@@ -6721,7 +6801,7 @@
       </p:sp>
       <p:sp>
         <p:nvSpPr>
-          <p:cNvPr id="25" name="shape-24"/>
+          <p:cNvPr id="26" name="shape-25"/>
           <p:cNvSpPr/>
           <p:nvPr/>
         </p:nvSpPr>
@@ -6743,7 +6823,7 @@
       </p:sp>
       <p:pic>
         <p:nvPicPr>
-          <p:cNvPr id="26" name="img-25" descr="preencoded.png">    </p:cNvPr>
+          <p:cNvPr id="27" name="img-26" descr="preencoded.png">    </p:cNvPr>
           <p:cNvPicPr>
             <a:picLocks noChangeAspect="1"/>
           </p:cNvPicPr>
@@ -6767,7 +6847,7 @@
       </p:pic>
       <p:sp>
         <p:nvSpPr>
-          <p:cNvPr id="27" name="text-26"/>
+          <p:cNvPr id="28" name="text-27"/>
           <p:cNvSpPr txBox="1"/>
           <p:nvPr/>
         </p:nvSpPr>
@@ -6809,7 +6889,7 @@
       </p:sp>
       <p:sp>
         <p:nvSpPr>
-          <p:cNvPr id="28" name="text-27"/>
+          <p:cNvPr id="29" name="text-28"/>
           <p:cNvSpPr txBox="1"/>
           <p:nvPr/>
         </p:nvSpPr>
@@ -6909,7 +6989,7 @@
           </a:solidFill>
           <a:ln w="12700">
             <a:solidFill>
-              <a:srgbClr val="0A0A0A"/>
+              <a:srgbClr val="2F7A33"/>
             </a:solidFill>
             <a:prstDash val="solid"/>
           </a:ln>
@@ -6969,7 +7049,7 @@
             <a:r>
               <a:rPr lang="en-US" sz="1000" spc="140" kern="0" dirty="0">
                 <a:solidFill>
-                  <a:srgbClr val="0A0A0A"/>
+                  <a:srgbClr val="2F7A33"/>
                 </a:solidFill>
                 <a:latin typeface="IBM Plex Mono" pitchFamily="34" charset="0"/>
                 <a:ea typeface="IBM Plex Mono" pitchFamily="34" charset="-122"/>
@@ -7025,7 +7105,27 @@
       </p:sp>
       <p:sp>
         <p:nvSpPr>
-          <p:cNvPr id="6" name="text-5"/>
+          <p:cNvPr id="6" name="shape-5"/>
+          <p:cNvSpPr/>
+          <p:nvPr/>
+        </p:nvSpPr>
+        <p:spPr>
+          <a:xfrm>
+            <a:off x="0" y="0"/>
+            <a:ext cx="6858000" cy="88900"/>
+          </a:xfrm>
+          <a:prstGeom prst="rect">
+            <a:avLst/>
+          </a:prstGeom>
+          <a:solidFill>
+            <a:srgbClr val="2F7A33"/>
+          </a:solidFill>
+          <a:ln/>
+        </p:spPr>
+      </p:sp>
+      <p:sp>
+        <p:nvSpPr>
+          <p:cNvPr id="7" name="text-6"/>
           <p:cNvSpPr txBox="1"/>
           <p:nvPr/>
         </p:nvSpPr>
@@ -7070,7 +7170,7 @@
             <a:r>
               <a:rPr lang="en-US" sz="5200" i="1" spc="-100" kern="0" dirty="0">
                 <a:solidFill>
-                  <a:srgbClr val="0A0A0A"/>
+                  <a:srgbClr val="2F7A33"/>
                 </a:solidFill>
                 <a:latin typeface="Noto Serif Display Light" pitchFamily="34" charset="0"/>
                 <a:ea typeface="Noto Serif Display Light" pitchFamily="34" charset="-122"/>
@@ -7084,7 +7184,7 @@
       </p:sp>
       <p:sp>
         <p:nvSpPr>
-          <p:cNvPr id="7" name="shape-6"/>
+          <p:cNvPr id="8" name="shape-7"/>
           <p:cNvSpPr/>
           <p:nvPr/>
         </p:nvSpPr>
@@ -7111,7 +7211,7 @@
       </p:sp>
       <p:sp>
         <p:nvSpPr>
-          <p:cNvPr id="8" name="shape-7"/>
+          <p:cNvPr id="9" name="shape-8"/>
           <p:cNvSpPr/>
           <p:nvPr/>
         </p:nvSpPr>
@@ -7133,7 +7233,7 @@
       </p:sp>
       <p:sp>
         <p:nvSpPr>
-          <p:cNvPr id="9" name="text-8"/>
+          <p:cNvPr id="10" name="text-9"/>
           <p:cNvSpPr txBox="1"/>
           <p:nvPr/>
         </p:nvSpPr>
@@ -7175,7 +7275,7 @@
       </p:sp>
       <p:sp>
         <p:nvSpPr>
-          <p:cNvPr id="10" name="text-9"/>
+          <p:cNvPr id="11" name="text-10"/>
           <p:cNvSpPr txBox="1"/>
           <p:nvPr/>
         </p:nvSpPr>
@@ -7217,7 +7317,7 @@
       </p:sp>
       <p:sp>
         <p:nvSpPr>
-          <p:cNvPr id="11" name="text-10"/>
+          <p:cNvPr id="12" name="text-11"/>
           <p:cNvSpPr txBox="1"/>
           <p:nvPr/>
         </p:nvSpPr>
@@ -7259,7 +7359,7 @@
       </p:sp>
       <p:sp>
         <p:nvSpPr>
-          <p:cNvPr id="12" name="shape-11"/>
+          <p:cNvPr id="13" name="shape-12"/>
           <p:cNvSpPr/>
           <p:nvPr/>
         </p:nvSpPr>
@@ -7274,14 +7374,14 @@
             </a:avLst>
           </a:prstGeom>
           <a:solidFill>
-            <a:srgbClr val="0A0A0A"/>
+            <a:srgbClr val="2F7A33"/>
           </a:solidFill>
           <a:ln/>
         </p:spPr>
       </p:sp>
       <p:sp>
         <p:nvSpPr>
-          <p:cNvPr id="13" name="shape-12"/>
+          <p:cNvPr id="14" name="shape-13"/>
           <p:cNvSpPr/>
           <p:nvPr/>
         </p:nvSpPr>
@@ -7298,7 +7398,7 @@
           </a:solidFill>
           <a:ln w="12700">
             <a:solidFill>
-              <a:srgbClr val="0A0A0A"/>
+              <a:srgbClr val="2F7A33"/>
             </a:solidFill>
             <a:prstDash val="solid"/>
           </a:ln>
@@ -7306,7 +7406,7 @@
       </p:sp>
       <p:pic>
         <p:nvPicPr>
-          <p:cNvPr id="14" name="svg-13" descr="preencoded.png">    </p:cNvPr>
+          <p:cNvPr id="15" name="svg-14" descr="preencoded.png">    </p:cNvPr>
           <p:cNvPicPr>
             <a:picLocks noChangeAspect="1"/>
           </p:cNvPicPr>
@@ -7330,7 +7430,7 @@
       </p:pic>
       <p:sp>
         <p:nvSpPr>
-          <p:cNvPr id="15" name="text-14"/>
+          <p:cNvPr id="16" name="text-15"/>
           <p:cNvSpPr txBox="1"/>
           <p:nvPr/>
         </p:nvSpPr>
@@ -7372,7 +7472,7 @@
       </p:sp>
       <p:pic>
         <p:nvPicPr>
-          <p:cNvPr id="16" name="svg-15" descr="preencoded.png">    </p:cNvPr>
+          <p:cNvPr id="17" name="svg-16" descr="preencoded.png">    </p:cNvPr>
           <p:cNvPicPr>
             <a:picLocks noChangeAspect="1"/>
           </p:cNvPicPr>
@@ -7396,7 +7496,7 @@
       </p:pic>
       <p:sp>
         <p:nvSpPr>
-          <p:cNvPr id="17" name="text-16"/>
+          <p:cNvPr id="18" name="text-17"/>
           <p:cNvSpPr txBox="1"/>
           <p:nvPr/>
         </p:nvSpPr>
@@ -7438,7 +7538,7 @@
       </p:sp>
       <p:sp>
         <p:nvSpPr>
-          <p:cNvPr id="18" name="text-17"/>
+          <p:cNvPr id="19" name="text-18"/>
           <p:cNvSpPr txBox="1"/>
           <p:nvPr/>
         </p:nvSpPr>
@@ -7480,7 +7580,7 @@
       </p:sp>
       <p:sp>
         <p:nvSpPr>
-          <p:cNvPr id="19" name="text-18"/>
+          <p:cNvPr id="20" name="text-19"/>
           <p:cNvSpPr txBox="1"/>
           <p:nvPr/>
         </p:nvSpPr>
@@ -7522,7 +7622,7 @@
       </p:sp>
       <p:sp>
         <p:nvSpPr>
-          <p:cNvPr id="20" name="text-19"/>
+          <p:cNvPr id="21" name="text-20"/>
           <p:cNvSpPr txBox="1"/>
           <p:nvPr/>
         </p:nvSpPr>
@@ -7564,7 +7664,7 @@
       </p:sp>
       <p:sp>
         <p:nvSpPr>
-          <p:cNvPr id="21" name="shape-20"/>
+          <p:cNvPr id="22" name="shape-21"/>
           <p:cNvSpPr/>
           <p:nvPr/>
         </p:nvSpPr>
@@ -7586,7 +7686,7 @@
       </p:sp>
       <p:sp>
         <p:nvSpPr>
-          <p:cNvPr id="22" name="text-21"/>
+          <p:cNvPr id="23" name="text-22"/>
           <p:cNvSpPr txBox="1"/>
           <p:nvPr/>
         </p:nvSpPr>
@@ -7628,7 +7728,7 @@
       </p:sp>
       <p:pic>
         <p:nvPicPr>
-          <p:cNvPr id="23" name="svg-22" descr="preencoded.png">    </p:cNvPr>
+          <p:cNvPr id="24" name="svg-23" descr="preencoded.png">    </p:cNvPr>
           <p:cNvPicPr>
             <a:picLocks noChangeAspect="1"/>
           </p:cNvPicPr>
@@ -7652,7 +7752,7 @@
       </p:pic>
       <p:sp>
         <p:nvSpPr>
-          <p:cNvPr id="24" name="shape-23"/>
+          <p:cNvPr id="25" name="shape-24"/>
           <p:cNvSpPr/>
           <p:nvPr/>
         </p:nvSpPr>
@@ -7679,7 +7779,7 @@
       </p:sp>
       <p:sp>
         <p:nvSpPr>
-          <p:cNvPr id="25" name="shape-24"/>
+          <p:cNvPr id="26" name="shape-25"/>
           <p:cNvSpPr/>
           <p:nvPr/>
         </p:nvSpPr>
@@ -7701,7 +7801,7 @@
       </p:sp>
       <p:pic>
         <p:nvPicPr>
-          <p:cNvPr id="26" name="img-25" descr="preencoded.png">    </p:cNvPr>
+          <p:cNvPr id="27" name="img-26" descr="preencoded.png">    </p:cNvPr>
           <p:cNvPicPr>
             <a:picLocks noChangeAspect="1"/>
           </p:cNvPicPr>
@@ -7725,7 +7825,7 @@
       </p:pic>
       <p:sp>
         <p:nvSpPr>
-          <p:cNvPr id="27" name="text-26"/>
+          <p:cNvPr id="28" name="text-27"/>
           <p:cNvSpPr txBox="1"/>
           <p:nvPr/>
         </p:nvSpPr>
@@ -7767,7 +7867,7 @@
       </p:sp>
       <p:sp>
         <p:nvSpPr>
-          <p:cNvPr id="28" name="text-27"/>
+          <p:cNvPr id="29" name="text-28"/>
           <p:cNvSpPr txBox="1"/>
           <p:nvPr/>
         </p:nvSpPr>

</xml_diff>